<commit_message>
Update Zip file for training
</commit_message>
<xml_diff>
--- a/deploy/LANDIS-II-SiteV3_0/Inter/LANDIS-II-Site User Guide_Presentation.pptx
+++ b/deploy/LANDIS-II-SiteV3_0/Inter/LANDIS-II-Site User Guide_Presentation.pptx
@@ -262,7 +262,7 @@
           <a:p>
             <a:fld id="{780C659C-950C-4219-97A5-5FA1345B82CF}" type="datetimeFigureOut">
               <a:rPr lang="en-US" smtClean="0"/>
-              <a:t>4/29/2026</a:t>
+              <a:t>5/13/2026</a:t>
             </a:fld>
             <a:endParaRPr lang="en-US"/>
           </a:p>
@@ -460,7 +460,7 @@
           <a:p>
             <a:fld id="{780C659C-950C-4219-97A5-5FA1345B82CF}" type="datetimeFigureOut">
               <a:rPr lang="en-US" smtClean="0"/>
-              <a:t>4/29/2026</a:t>
+              <a:t>5/13/2026</a:t>
             </a:fld>
             <a:endParaRPr lang="en-US"/>
           </a:p>
@@ -668,7 +668,7 @@
           <a:p>
             <a:fld id="{780C659C-950C-4219-97A5-5FA1345B82CF}" type="datetimeFigureOut">
               <a:rPr lang="en-US" smtClean="0"/>
-              <a:t>4/29/2026</a:t>
+              <a:t>5/13/2026</a:t>
             </a:fld>
             <a:endParaRPr lang="en-US"/>
           </a:p>
@@ -866,7 +866,7 @@
           <a:p>
             <a:fld id="{780C659C-950C-4219-97A5-5FA1345B82CF}" type="datetimeFigureOut">
               <a:rPr lang="en-US" smtClean="0"/>
-              <a:t>4/29/2026</a:t>
+              <a:t>5/13/2026</a:t>
             </a:fld>
             <a:endParaRPr lang="en-US"/>
           </a:p>
@@ -1141,7 +1141,7 @@
           <a:p>
             <a:fld id="{780C659C-950C-4219-97A5-5FA1345B82CF}" type="datetimeFigureOut">
               <a:rPr lang="en-US" smtClean="0"/>
-              <a:t>4/29/2026</a:t>
+              <a:t>5/13/2026</a:t>
             </a:fld>
             <a:endParaRPr lang="en-US"/>
           </a:p>
@@ -1406,7 +1406,7 @@
           <a:p>
             <a:fld id="{780C659C-950C-4219-97A5-5FA1345B82CF}" type="datetimeFigureOut">
               <a:rPr lang="en-US" smtClean="0"/>
-              <a:t>4/29/2026</a:t>
+              <a:t>5/13/2026</a:t>
             </a:fld>
             <a:endParaRPr lang="en-US"/>
           </a:p>
@@ -1818,7 +1818,7 @@
           <a:p>
             <a:fld id="{780C659C-950C-4219-97A5-5FA1345B82CF}" type="datetimeFigureOut">
               <a:rPr lang="en-US" smtClean="0"/>
-              <a:t>4/29/2026</a:t>
+              <a:t>5/13/2026</a:t>
             </a:fld>
             <a:endParaRPr lang="en-US"/>
           </a:p>
@@ -1959,7 +1959,7 @@
           <a:p>
             <a:fld id="{780C659C-950C-4219-97A5-5FA1345B82CF}" type="datetimeFigureOut">
               <a:rPr lang="en-US" smtClean="0"/>
-              <a:t>4/29/2026</a:t>
+              <a:t>5/13/2026</a:t>
             </a:fld>
             <a:endParaRPr lang="en-US"/>
           </a:p>
@@ -2072,7 +2072,7 @@
           <a:p>
             <a:fld id="{780C659C-950C-4219-97A5-5FA1345B82CF}" type="datetimeFigureOut">
               <a:rPr lang="en-US" smtClean="0"/>
-              <a:t>4/29/2026</a:t>
+              <a:t>5/13/2026</a:t>
             </a:fld>
             <a:endParaRPr lang="en-US"/>
           </a:p>
@@ -2383,7 +2383,7 @@
           <a:p>
             <a:fld id="{780C659C-950C-4219-97A5-5FA1345B82CF}" type="datetimeFigureOut">
               <a:rPr lang="en-US" smtClean="0"/>
-              <a:t>4/29/2026</a:t>
+              <a:t>5/13/2026</a:t>
             </a:fld>
             <a:endParaRPr lang="en-US"/>
           </a:p>
@@ -2671,7 +2671,7 @@
           <a:p>
             <a:fld id="{780C659C-950C-4219-97A5-5FA1345B82CF}" type="datetimeFigureOut">
               <a:rPr lang="en-US" smtClean="0"/>
-              <a:t>4/29/2026</a:t>
+              <a:t>5/13/2026</a:t>
             </a:fld>
             <a:endParaRPr lang="en-US"/>
           </a:p>
@@ -2912,7 +2912,7 @@
           <a:p>
             <a:fld id="{780C659C-950C-4219-97A5-5FA1345B82CF}" type="datetimeFigureOut">
               <a:rPr lang="en-US" smtClean="0"/>
-              <a:t>4/29/2026</a:t>
+              <a:t>5/13/2026</a:t>
             </a:fld>
             <a:endParaRPr lang="en-US"/>
           </a:p>
@@ -3710,10 +3710,10 @@
       </p:grpSpPr>
       <p:pic>
         <p:nvPicPr>
-          <p:cNvPr id="4" name="Picture 3">
-            <a:extLst>
-              <a:ext uri="{FF2B5EF4-FFF2-40B4-BE49-F238E27FC236}">
-                <a16:creationId xmlns:a16="http://schemas.microsoft.com/office/drawing/2014/main" id="{04F00592-5251-3DB9-5152-8E27CBD5DE48}"/>
+          <p:cNvPr id="3" name="Picture 2">
+            <a:extLst>
+              <a:ext uri="{FF2B5EF4-FFF2-40B4-BE49-F238E27FC236}">
+                <a16:creationId xmlns:a16="http://schemas.microsoft.com/office/drawing/2014/main" id="{DC648B14-1001-DFA0-D7BB-CED618326AC0}"/>
               </a:ext>
             </a:extLst>
           </p:cNvPr>
@@ -3724,15 +3724,14 @@
         </p:nvPicPr>
         <p:blipFill>
           <a:blip r:embed="rId2"/>
-          <a:srcRect l="748" r="1553" b="3289"/>
           <a:stretch>
             <a:fillRect/>
           </a:stretch>
         </p:blipFill>
         <p:spPr>
           <a:xfrm>
-            <a:off x="2145792" y="112776"/>
-            <a:ext cx="7400544" cy="6632448"/>
+            <a:off x="2257510" y="0"/>
+            <a:ext cx="7676980" cy="6858000"/>
           </a:xfrm>
           <a:prstGeom prst="rect">
             <a:avLst/>
@@ -3777,10 +3776,10 @@
       </p:grpSpPr>
       <p:grpSp>
         <p:nvGrpSpPr>
-          <p:cNvPr id="16" name="Group 15">
-            <a:extLst>
-              <a:ext uri="{FF2B5EF4-FFF2-40B4-BE49-F238E27FC236}">
-                <a16:creationId xmlns:a16="http://schemas.microsoft.com/office/drawing/2014/main" id="{85591B07-5052-FCA9-F785-9C33A1866DA6}"/>
+          <p:cNvPr id="2" name="Group 1">
+            <a:extLst>
+              <a:ext uri="{FF2B5EF4-FFF2-40B4-BE49-F238E27FC236}">
+                <a16:creationId xmlns:a16="http://schemas.microsoft.com/office/drawing/2014/main" id="{2220C524-6FEF-CEDA-2612-F0D591BC2AB2}"/>
               </a:ext>
             </a:extLst>
           </p:cNvPr>
@@ -3789,18 +3788,18 @@
         </p:nvGrpSpPr>
         <p:grpSpPr>
           <a:xfrm>
-            <a:off x="2090056" y="197833"/>
-            <a:ext cx="7149004" cy="6462334"/>
-            <a:chOff x="2090056" y="197833"/>
-            <a:chExt cx="7149004" cy="6462334"/>
+            <a:off x="2062438" y="0"/>
+            <a:ext cx="7676980" cy="6858000"/>
+            <a:chOff x="2062438" y="0"/>
+            <a:chExt cx="7676980" cy="6858000"/>
           </a:xfrm>
         </p:grpSpPr>
         <p:pic>
           <p:nvPicPr>
-            <p:cNvPr id="15" name="Picture 14">
+            <p:cNvPr id="3" name="Picture 2">
               <a:extLst>
                 <a:ext uri="{FF2B5EF4-FFF2-40B4-BE49-F238E27FC236}">
-                  <a16:creationId xmlns:a16="http://schemas.microsoft.com/office/drawing/2014/main" id="{D2C5B4CD-1527-384A-C3E1-90899D07E093}"/>
+                  <a16:creationId xmlns:a16="http://schemas.microsoft.com/office/drawing/2014/main" id="{C1CC2AB7-7C69-CFB9-B760-B26F81842148}"/>
                 </a:ext>
               </a:extLst>
             </p:cNvPr>
@@ -3817,8 +3816,8 @@
           </p:blipFill>
           <p:spPr>
             <a:xfrm>
-              <a:off x="2090056" y="197833"/>
-              <a:ext cx="7149004" cy="6407015"/>
+              <a:off x="2062438" y="0"/>
+              <a:ext cx="7676980" cy="6858000"/>
             </a:xfrm>
             <a:prstGeom prst="rect">
               <a:avLst/>
@@ -3839,8 +3838,8 @@
           </p:nvSpPr>
           <p:spPr>
             <a:xfrm>
-              <a:off x="2090056" y="401076"/>
-              <a:ext cx="7149003" cy="163776"/>
+              <a:off x="2090056" y="252919"/>
+              <a:ext cx="7249016" cy="332297"/>
             </a:xfrm>
             <a:prstGeom prst="rect">
               <a:avLst/>
@@ -3892,7 +3891,7 @@
           <p:spPr>
             <a:xfrm>
               <a:off x="2090056" y="609600"/>
-              <a:ext cx="7149003" cy="202843"/>
+              <a:ext cx="7249016" cy="280416"/>
             </a:xfrm>
             <a:prstGeom prst="rect">
               <a:avLst/>
@@ -3943,8 +3942,8 @@
           </p:nvSpPr>
           <p:spPr>
             <a:xfrm>
-              <a:off x="2090056" y="836827"/>
-              <a:ext cx="7149003" cy="3735173"/>
+              <a:off x="2090056" y="902208"/>
+              <a:ext cx="7249016" cy="3669792"/>
             </a:xfrm>
             <a:prstGeom prst="rect">
               <a:avLst/>
@@ -3996,7 +3995,7 @@
           <p:spPr>
             <a:xfrm>
               <a:off x="2090056" y="4572000"/>
-              <a:ext cx="5322679" cy="2088167"/>
+              <a:ext cx="5468984" cy="2088167"/>
             </a:xfrm>
             <a:prstGeom prst="rect">
               <a:avLst/>

</xml_diff>